<commit_message>
Add 초1 수학 8-14 and 초1 국어 문장·문학 lessons; tool improvements
- 수학: 세 수의 덧셈과 뺄셈, 10이 되는 더하기, 받아올림이 있는 덧셈,
  받아내림이 있는 뺄셈, 두 자리 수의 덧셈과 뺄셈, 몇째, 짝수와 홀수
- 국어: 문장으로 말하고 쓰기, 문장 부호, 그림일기, 바르게 듣고 말하기,
  동시 읽고 느낌 말하기(original poems), 그림책 읽고 이야기하기
  (original story)
- ten-frames can colour two groups (split), long slide titles shrink to
  fit instead of wrapping, worksheet drawing boxes print before writing
  lines and keep spaces
- plan: 'pre!' states the real prerequisite instead of the previous
  lesson; 세 수의 덧셈과 뺄셈 and 두 자리 수의 덧셈과 뺄셈 use it;
  new skeletons start as 계획

Co-Authored-By: Claude Opus 5.5 <noreply@anthropic.com>
Claude-Session: https://claude.ai/code/session_01EDFMZ4KdXfygs8AmnQ2tjw
</commit_message>
<xml_diff>
--- a/dist/초1/국어/대화와문학/초1_국어_대화와문학_01_바르게듣고차례지켜말하기.pptx
+++ b/dist/초1/국어/대화와문학/초1_국어_대화와문학_01_바르게듣고차례지켜말하기.pptx
@@ -119,19 +119,19 @@
   <p:extLst>
     <p:ext uri="{521415D9-36F7-43E2-AB2F-B90AF26B5E84}">
       <p14:sectionLst xmlns:p14="http://schemas.microsoft.com/office/powerpoint/2010/main">
-        <p14:section name="도입" id="{840e3ac9-3511-595d-d07a-bafa97d44683}">
+        <p14:section name="도입" id="{3a87caad-e1a6-d8bc-6251-99b25b3ebbac}">
           <p14:sldIdLst>
             <p14:sldId id="256"/>
             <p14:sldId id="257"/>
           </p14:sldIdLst>
         </p14:section>
-        <p14:section name="개념" id="{514d037c-080e-3b70-61ea-922152654f11}">
+        <p14:section name="개념" id="{c2e57c60-884f-30cd-4a3e-d9fb5645edf7}">
           <p14:sldIdLst>
             <p14:sldId id="258"/>
             <p14:sldId id="259"/>
           </p14:sldIdLst>
         </p14:section>
-        <p14:section name="연습" id="{0d80840d-3071-e2c5-349f-94c181df66db}">
+        <p14:section name="연습" id="{7c433e79-9965-d972-6abe-fa73a9f4429a}">
           <p14:sldIdLst>
             <p14:sldId id="260"/>
             <p14:sldId id="261"/>
@@ -139,19 +139,19 @@
             <p14:sldId id="263"/>
           </p14:sldIdLst>
         </p14:section>
-        <p14:section name="확인" id="{1954b4c1-9b46-5001-6775-30f12105f9a7}">
+        <p14:section name="확인" id="{beec5c79-8571-3799-40a5-9e08fcfa1f9c}">
           <p14:sldIdLst>
             <p14:sldId id="264"/>
             <p14:sldId id="265"/>
             <p14:sldId id="266"/>
           </p14:sldIdLst>
         </p14:section>
-        <p14:section name="정리" id="{94df43e8-305e-7657-130c-a6812d98fe5f}">
+        <p14:section name="정리" id="{61618e9c-971f-5ea8-09f0-165a0f67762e}">
           <p14:sldIdLst>
             <p14:sldId id="267"/>
           </p14:sldIdLst>
         </p14:section>
-        <p14:section name="보충" id="{1d87ce6b-e815-c02c-7888-553d59a2e556}">
+        <p14:section name="보충" id="{8402dc00-b6b3-d12a-9cd8-a1364575e124}">
           <p14:sldIdLst>
             <p14:sldId id="268"/>
           </p14:sldIdLst>

</xml_diff>